<commit_message>
feat: notas del orador con el guion hablado en las 47 diapositivas
Las notas eran recordatorios de una linea. Ahora cada diapositiva lleva lo que
hay que decir ahi, en primera persona y listo para leerse, organizado con
etiquetas: USTED DICE (texto hablado), USTED HACE (indicacion escenica),
SI SE LO PREGUNTAN y TRANSICION.

Incluye las cuatro diapositivas separadoras, que no tenian notas.

Unas 6.100 palabras en total, alrededor de 130 por diapositiva, con ortografia
completa (tildes, enes y signos de apertura) por tratarse de texto que se lee
en tarima.

Co-Authored-By: Claude Opus 5 <noreply@anthropic.com>
Claude-Session: https://claude.ai/code/session_01Mghz8JHS7oZ3VrakW6LzVy
</commit_message>
<xml_diff>
--- a/conferencias/organismos-de-socorro-y-la-biblia/Organismos de Socorro y la Biblia.pptx
+++ b/conferencias/organismos-de-socorro-y-la-biblia/Organismos de Socorro y la Biblia.pptx
@@ -548,7 +548,9 @@
           <a:p>
             <a:r>
               <a:rPr lang="en-US" dirty="0"/>
-              <a:t>No salude todavia. Entre en frio con la pregunta de la diapositiva 2.</a:t>
+              <a:t>ANTES DE EMPEZAR
+No salude. No agradezca. No presente el tema todavía. Entre en frío con la pregunta de la diapositiva siguiente: la atención se gana en los primeros diez segundos, y un saludo largo la gasta.
+Si tiene que presentarse, hágalo después de la dinámica de la salida, en una sola frase: «Mi nombre es Carlos Contreras, y vengo a hablarles de dos mundos que casi nunca se juntan: los organismos de socorro y la Biblia.»</a:t>
             </a:r>
             <a:endParaRPr lang="en-US" dirty="0"/>
           </a:p>
@@ -636,7 +638,14 @@
           <a:p>
             <a:r>
               <a:rPr lang="en-US" dirty="0"/>
-              <a:t>Corregir el mito del triangulo de la vida es importante: circula mucho en redes.</a:t>
+              <a:t>USTED DICE
+«Ahora lo que NO se hace, que es tan importante como lo anterior.
+No corra mientras tiembla: la mayoría de las lesiones viene de caídas y de objetos que caen, no de derrumbes.
+No se pare en el marco de la puerta: en construcción moderna no es más fuerte que el resto de la pared. Eso lo aprendimos de casas de adobe y se nos quedó pegado.
+Nunca el ascensor. Ni durante, ni después.
+Y el último me importa mucho: el llamado “triángulo de la vida”. Circula muchísimo por redes sociales, y los organismos de socorro internacionales NO lo recomiendan. Si usted lo ha compartido, deje de hacerlo.»
+USTED HACE
+Cierre con la frase de abajo: en la emergencia usted cae a la altura de su entrenamiento.</a:t>
             </a:r>
             <a:endParaRPr lang="en-US" dirty="0"/>
           </a:p>
@@ -724,7 +733,15 @@
           <a:p>
             <a:r>
               <a:rPr lang="en-US" dirty="0"/>
-              <a:t>Si quedo atrapado: no gritar sin necesidad, golpear una tuberia a intervalos y cubrirse la boca.</a:t>
+              <a:t>USTED DICE
+«Paró el temblor. Los minutos que siguen deciden mucho.
+Espere réplicas: van a venir, y son las que tumban lo que quedó debilitado.
+No encienda fósforos, velas ni el interruptor de la luz hasta descartar fuga de gas. Si huele a gas: cierre la válvula, ventile y salga.
+Revise heridos a su alrededor antes de salir corriendo.
+Salga con calzado cerrado: el piso queda lleno de vidrio. Por eso los zapatos van debajo de la cama.
+Y use el celular para mensajes de texto, no para llamadas: la red se satura, y el texto pasa cuando la llamada no.»
+SI SE LO PREGUNTAN
+Si queda atrapado: no grite sin necesidad, porque agota y hace tragar polvo. Golpee una tubería o una pared a intervalos regulares, y cúbrase la boca.</a:t>
             </a:r>
             <a:endParaRPr lang="en-US" dirty="0"/>
           </a:p>
@@ -812,7 +829,13 @@
           <a:p>
             <a:r>
               <a:rPr lang="en-US" dirty="0"/>
-              <a:t>Que mas de una persona de la casa sepa donde se cierran el gas y la electricidad.</a:t>
+              <a:t>USTED DICE
+«Dos cosas que puede hacer esta semana, sin gastar casi nada.
+Primera: anclar a la pared lo que puede caerle encima. Estantes altos, armarios, el televisor, el calentador. Y no dormir debajo de repisas, cuadros pesados ni espejos.
+Segunda, y es la medida más barata y más subestimada que existe: un par de zapatos y una linterna debajo de la cama.
+Porque el sismo no avisa. No hay boletín, no hay temporada, no hay días de preparación. Todo lo que usted va a hacer en un terremoto lo decidió antes.»
+AGREGUE
+Que más de una persona de la casa sepa dónde está y cómo se cierra la llave del gas, y dónde está el interruptor principal de la electricidad.</a:t>
             </a:r>
             <a:endParaRPr lang="en-US" dirty="0"/>
           </a:p>
@@ -900,7 +923,11 @@
           <a:p>
             <a:r>
               <a:rPr lang="en-US" dirty="0"/>
-              <a:t>Es el unico desastre mayor que da dias de aviso. Su mortalidad es, en su mayoria, evitable.</a:t>
+              <a:t>USTED DICE
+«El huracán es el único desastre que le avisa con días de anticipación. Días. El terremoto no avisa. El huracán sí. Y aun así seguimos perdiendo gente.
+¿Por qué? Porque ver el mal no basta. El versículo dice que el avisado ve Y SE ESCONDE. Hay que hacer las dos.»
+USTED HACE
+Subraye con la voz las tres palabras resaltadas: “y se esconde”. La mortalidad por ciclón es, en su mayoría, mortalidad evitable — y eso es exactamente lo que está diciendo Proverbios.</a:t>
             </a:r>
             <a:endParaRPr lang="en-US" dirty="0"/>
           </a:p>
@@ -988,7 +1015,11 @@
           <a:p>
             <a:r>
               <a:rPr lang="en-US" dirty="0"/>
-              <a:t>Decidalo hoy, no con el viento encima. Evacuar tarde es la decision que mata.</a:t>
+              <a:t>USTED DICE
+«Hay una pregunta que se contesta en la calma, no con el viento encima: ¿mi casa es de permanencia o de evacuación?
+Si usted vive en zona baja, cerca de una cañada, de un río o del mar, usted evacúa. Decídalo hoy. Averigüe hoy cuál es su refugio y cómo se llega caminando.»
+Repase la lista de la derecha sin detenerse en cada punto; lo importante es el mensaje de abajo:
+«Si le toca evacuar, evacúese temprano. Evacuar tarde es la decisión que mata: se hace de noche, con viento, con las vías ya inundadas. Y lleve la mascota, porque mucha gente se niega a salir por no dejarla.»</a:t>
             </a:r>
             <a:endParaRPr lang="en-US" dirty="0"/>
           </a:p>
@@ -1076,7 +1107,13 @@
           <a:p>
             <a:r>
               <a:rPr lang="en-US" dirty="0"/>
-              <a:t>Mucha gente muere por salir cuando todo se calmo. No salga hasta que la autoridad lo diga.</a:t>
+              <a:t>USTED DICE
+«Esta es la trampa que más gente ha matado en un ciclón.
+De pronto todo se calma. El viento para, sale un pedazo de cielo, se oyen los pájaros. La gente sale a ver los daños, a buscar a un familiar, a mover el carro.
+Ese es el ojo del huracán. Dura de minutos a una hora. Y después el viento vuelve, del lado contrario, con la misma fuerza o más.
+No salga. No salga hasta que la autoridad lo diga.»
+USTED HACE
+Dígalo despacio y deje un silencio. Es la diapositiva más importante del bloque de ciclones.</a:t>
             </a:r>
             <a:endParaRPr lang="en-US" dirty="0"/>
           </a:p>
@@ -1164,7 +1201,12 @@
           <a:p>
             <a:r>
               <a:rPr lang="en-US" dirty="0"/>
-              <a:t>Treinta centimetros de agua en movimiento derriban a un adulto; sesenta arrastran un vehiculo.</a:t>
+              <a:t>USTED DICE
+«Y ahora la fase que más muertes causa, que no es el huracán: es el día después.
+No cruce agua corriendo, ni a pie ni en vehículo. Treinta centímetros de agua en movimiento derriban a un adulto. Sesenta arrastran un vehículo. Si la vía está inundada, dé la vuelta. Es la muerte más evitable de todas, y la que más repetimos cada año.
+Cables caídos: siempre energizados. Y cuidado con los charcos donde haya cables.
+Hierva o trate el agua: la segunda ola del desastre es sanitaria — diarrea, leptospirosis.
+Y la planta eléctrica: jamás dentro de la casa, del garaje, ni cerca de una ventana. El monóxido de carbono no huele, no se ve, y mata familias enteras dormidas.»</a:t>
             </a:r>
             <a:endParaRPr lang="en-US" dirty="0"/>
           </a:p>
@@ -1252,7 +1294,14 @@
           <a:p>
             <a:r>
               <a:rPr lang="en-US" dirty="0"/>
-              <a:t>El Caribe ha tenido maremotos destructivos con perdida de vidas en nuestras propias costas.</a:t>
+              <a:t>USTED DICE
+«En un maremoto de origen cercano, entre el sismo y la ola pueden pasar pocos minutos. Ningún sistema oficial es más rápido que la señal natural. Por eso hay que conocerlas.
+Primera: un sismo tan fuerte que le cuesta mantenerse de pie, o uno más débil pero que dura mucho, si usted está en la costa.
+Segunda: el mar se comporta raro. Se retira y deja el fondo al descubierto, o sube de golpe fuera de la marea.
+Tercera: un rugido desde el mar, parecido a un tren o a un avión.
+Cualquiera de las tres, sola, basta para evacuar.»
+CONTEXTO
+«Esto no es teórico para nosotros. El Caribe ha tenido maremotos destructivos, con pérdida de vidas en nuestras propias costas. La memoria corta es la aliada del desastre.»</a:t>
             </a:r>
             <a:endParaRPr lang="en-US" dirty="0"/>
           </a:p>
@@ -1340,7 +1389,14 @@
           <a:p>
             <a:r>
               <a:rPr lang="en-US" dirty="0"/>
-              <a:t>A pie, no en vehiculo: el tapon de vehiculos ha matado a mas gente que la ola.</a:t>
+              <a:t>USTED DICE
+«Y aquí está la regla — quiero que se la lleven grabada: no espere el aviso oficial. El sismo es el aviso.
+Suba. Lo más alto que pueda.
+Aléjese. Lo más tierra adentro que alcance.
+A pie, no en vehículo: el tapón de vehículos ha matado a más gente que la ola.
+Y no regrese. La primera ola no es la mayor, y el peligro dura horas. Se regresa cuando la autoridad lo autoriza, no antes.»
+SI SE LO PREGUNTAN
+Si no hay terreno alto y no se puede salir a tiempo, el último recurso es subir a los pisos superiores de una edificación alta y sólida de concreto. Y si está embarcado mar adentro: no entre a puerto, váyase a aguas profundas.</a:t>
             </a:r>
             <a:endParaRPr lang="en-US" dirty="0"/>
           </a:p>
@@ -1428,7 +1484,13 @@
           <a:p>
             <a:r>
               <a:rPr lang="en-US" dirty="0"/>
-              <a:t>La mujer de Lot: el que se detiene o vuelve atras en una evacuacion, perece.</a:t>
+              <a:t>USTED DICE
+«Escuchen esa orden, palabra por palabra: “escapa por tu vida; no mires tras ti… escapa al monte”.
+Sube. No recojas. No mires atrás.
+Ese es, literalmente, el protocolo de evacuación ante un maremoto. Y está en Génesis 19.»
+AGREGUE
+«Y fíjense en lo que le pasó a la mujer de Lot. El que se detiene o vuelve atrás en una evacuación, perece. No es una leyenda para asustar niños: es lo que pasa en toda evacuación real, cuando alguien regresa por algo.»
+También vale mencionar que al yerno de Lot “le pareció como que se burlaba”. La incredulidad ante la alerta cuesta vidas.</a:t>
             </a:r>
             <a:endParaRPr lang="en-US" dirty="0"/>
           </a:p>
@@ -1516,7 +1578,12 @@
           <a:p>
             <a:r>
               <a:rPr lang="en-US" dirty="0"/>
-              <a:t>Deje el silencio. No lo llene. La incomodidad es el punto.</a:t>
+              <a:t>USTED DICE
+«Voy a empezar con una pregunta incómoda, y quiero que la contesten en silencio, para ustedes mismos.
+Si en este momento, ahora mismo, esta sala se comenzara a mover… ¿usted sabe qué haría en los próximos diez segundos?
+No lo que siente. Lo que haría.»
+USTED HACE
+Deje el silencio. No lo llene. La incomodidad es el punto de esta diapositiva: casi nadie tiene respuesta, y esa es la conferencia entera.</a:t>
             </a:r>
             <a:endParaRPr lang="en-US" dirty="0"/>
           </a:p>
@@ -1604,7 +1671,14 @@
           <a:p>
             <a:r>
               <a:rPr lang="en-US" dirty="0"/>
-              <a:t>Dios le esta dando a Israel un codigo de construccion: baranda obligatoria en la azotea.</a:t>
+              <a:t>USTED DICE
+«Deténganse en este versículo, porque es de los más sorprendentes de la Biblia.
+Dios le está dando a Israel un código de construcción. Baranda obligatoria en la azotea. ¿Por qué? Escuchen la razón: “para que no eches culpa de sangre sobre tu casa”.
+Es decir: si alguien se cae porque tú no pusiste la baranda, eso es culpa tuya delante de Dios.
+Léanlo otra vez. La negligencia en seguridad, en la Biblia, tiene categoría moral. No es un descuido administrativo. Es sangre.
+Eso es lo que Dios piensa de la prevención.»
+USTED HACE
+Esta diapositiva sostiene todo el bloque técnico. No la pase rápido.</a:t>
             </a:r>
             <a:endParaRPr lang="en-US" dirty="0"/>
           </a:p>
@@ -1692,7 +1766,13 @@
           <a:p>
             <a:r>
               <a:rPr lang="en-US" dirty="0"/>
-              <a:t>El detector de humo es el aparato con mejor relacion costo-vida que existe en una casa.</a:t>
+              <a:t>USTED DICE
+«El incendio casi nunca empieza donde uno cree. Empieza aquí:
+Electricidad: tomacorrientes sobrecargados, extensiones encadenadas, cables debajo de alfombras. Un tomacorriente tibio o un olor a quemado es una advertencia, no un detalle.
+La cocina: nunca deje aceite al fuego sin vigilancia. Y si el aceite se enciende, jamás le eche agua: apague la hornilla y tape el sartén.
+El gas: si huele a gas, no encienda la luz, no use el celular, no genere chispa. Cierre la válvula, ventile y salga. Llame desde afuera.
+Velas: nunca sin vigilancia, nunca al dormirse. En apagón prefiera linterna.
+Y el detector de humo: pruébelo cada mes, cambie la batería cada año. Es el aparato con mejor relación costo-vida que existe en una casa. Si suena cuando usted cocina, reubíquelo — no le quite la batería. Un detector sin batería es un detector que no existe.»</a:t>
             </a:r>
             <a:endParaRPr lang="en-US" dirty="0"/>
           </a:p>
@@ -1780,7 +1860,14 @@
           <a:p>
             <a:r>
               <a:rPr lang="en-US" dirty="0"/>
-              <a:t>Un extintor comun dura entre 10 y 20 segundos. Usted tiene un solo intento.</a:t>
+              <a:t>USTED DICE
+«Cuatro acciones, y se aprenden en treinta segundos.
+Hale el pasador de seguridad. Apunte a la BASE de la llama, no a las llamas. Apriete la palanca. Y barra de lado a lado.
+Apuntar a la base es donde falla todo el mundo: la gente le tira al fuego que ve, y el fuego que ve no es el que lo alimenta.»
+LA REGLA DE DECISIÓN — es lo más importante de la diapositiva:
+«Un extintor sirve para un fuego pequeño y contenido, en su inicio, con la salida a su espalda y con alguien que ya llamó a los bomberos.
+Si el fuego está por encima de su cintura, si hay humo denso, si el fuego está entre usted y la salida, o si tiene dudas: no lo pelee. Salga y llame.
+Un extintor común dura entre diez y veinte segundos. Usted tiene un solo intento.»</a:t>
             </a:r>
             <a:endParaRPr lang="en-US" dirty="0"/>
           </a:p>
@@ -1868,7 +1955,15 @@
           <a:p>
             <a:r>
               <a:rPr lang="en-US" dirty="0"/>
-              <a:t>Si queda atrapado: selle rendijas, hagase visible desde la ventana, llame indicando ubicacion exacta.</a:t>
+              <a:t>USTED DICE
+«Si no se puede apagar, hay que salir. Y salir bien.
+Con humo: agáchese y gatee. El aire respirable y frío está cerca del piso. Arriba está el humo caliente — y el humo es lo que mata, no la llama.
+Antes de abrir una puerta, tóquela con el DORSO de la mano. Con el dorso, porque si quema usted retira la mano por reflejo sin quemarse la palma. Si está caliente, no abra: busque otra ruta.
+Nunca el ascensor.
+Punto de encuentro afuera y conteo de personas. Y nadie vuelve a entrar. Por nada: ni por documentos, ni por mascotas, ni por recuerdos.
+Y si su ropa se enciende: deténgase, tírese al piso y ruede.»
+SI SE LO PREGUNTAN
+Si queda atrapado en una habitación: selle las rendijas con ropa o toallas, hágase visible desde la ventana y llame indicando su ubicación exacta.</a:t>
             </a:r>
             <a:endParaRPr lang="en-US" dirty="0"/>
           </a:p>
@@ -1956,7 +2051,15 @@
           <a:p>
             <a:r>
               <a:rPr lang="en-US" dirty="0"/>
-              <a:t>Al llamar: que paso, donde exactamente, cuantos lesionados, que riesgos hay, quien es usted.</a:t>
+              <a:t>USTED DICE
+«Miren la secuencia del buen samaritano: se acerca, evalúa, trata la herida con lo que tiene, traslada al herido, lo entrega a un nivel de cuidado mayor y paga la atención continua.
+Eso es, literalmente, la cadena de atención prehospitalaria. Está en Lucas 10. En el siglo primero.
+Y lo primero, siempre, son tres pasos.
+Proteger: su seguridad primero. Un socorrista herido es un paciente más, no una ayuda.
+Avisar: llame, o señale a una persona concreta con el dedo para que llame. Si usted grita “que alguien llame”, nadie llama.
+Socorrer: atienda primero lo que mata más rápido.»
+CÓMO SE LLAMA A EMERGENCIAS
+Qué pasó, dónde exactamente con una referencia visible, cuántos lesionados, qué riesgos hay en el lugar, y quién es usted. No cuelgue hasta que el operador lo indique.</a:t>
             </a:r>
             <a:endParaRPr lang="en-US" dirty="0"/>
           </a:p>
@@ -2044,7 +2147,17 @@
           <a:p>
             <a:r>
               <a:rPr lang="en-US" dirty="0"/>
-              <a:t>No quiero que salga sintiendose entrenado. Quiero que salga inscribiendose en un entrenamiento.</a:t>
+              <a:t>USTED DICE
+«Cuatro cosas que todo cristiano debería saber hacer.
+Hemorragia: presión directa, firme y sostenida, con lo más limpio que tenga. No suelte para ver cómo va.
+Atragantamiento: si la persona tose con fuerza, no interfiera — la tos es más eficaz que usted. Si no puede toser, hablar ni respirar, compresiones abdominales.
+Paro cardíaco: si no responde y no respira normal, compresiones fuertes y rápidas en el centro del pecho, sin parar.
+Quemaduras: agua a temperatura ambiente unos veinte minutos. Ni hielo, ni pasta de dientes, ni aceite, ni café, ni sábila. Agua.»
+Y AHORA LO MÁS IMPORTANTE — dígalo mirando a la gente:
+«Esto que acabo de decir no lo certifica esta conferencia. Yo se lo presento; la Cruz Roja, los bomberos y Defensa Civil se lo enseñan y se lo certifican.
+Yo no quiero que usted salga de aquí sintiéndose entrenado. Quiero que salga de aquí inscribiéndose en un entrenamiento.»
+TRANSICIÓN
+«Ya sabemos qué hacer con las manos. Ahora la pregunta grande: ¿y qué dice Dios de todo esto? Porque alguien está pensando: ¿y esto no es falta de fe?»</a:t>
             </a:r>
             <a:endParaRPr lang="en-US" dirty="0"/>
           </a:p>
@@ -2132,7 +2245,13 @@
           <a:p>
             <a:r>
               <a:rPr lang="en-US" dirty="0"/>
-              <a:t/>
+              <a:t>BLOQUE 2 · 13 minutos
+Este es el corazón teológico de la conferencia. Si le falta tiempo, recórtele minutos al Bloque 1, nunca a este.
+USTED DICE
+«Ya sabemos qué hacer con las manos. Ahora la pregunta grande, la que nos trajo aquí: ¿y qué dice Dios de todo esto?
+Porque yo sé que alguien está pensando: pastor, ¿y todo esto no es falta de fe?»
+EL RECORRIDO
+Dios habla antes del desastre. Dios habla por medio de gente que avisa. Dios habla en medio de la emergencia. Y Dios habla después, mandando a socorrer.</a:t>
             </a:r>
             <a:endParaRPr lang="en-US" dirty="0"/>
           </a:p>
@@ -2220,7 +2339,17 @@
           <a:p>
             <a:r>
               <a:rPr lang="en-US" dirty="0"/>
-              <a:t>Dios no es un Dios de sorpresas crueles.</a:t>
+              <a:t>USTED DICE
+«Repase la Escritura y verá un patrón que se repite: antes del desastre, Dios habla.
+A Noé le avisó del diluvio con generaciones de anticipación.
+A Egipto le avisó del granizo, con hora anunciada.
+A Lot le avisó de Sodoma y lo sacó de la mano.
+A José le avisó del hambre con siete años de anticipación.
+Por medio de Agabo avisó de una hambruna que venía sobre el mundo.
+Y a Pablo le mostró el naufragio antes de que zarparan.
+Dios no es un Dios de sorpresas crueles. Dios avisa. El problema nunca ha sido el silencio de Dios: ha sido la sordera del hombre.»
+USTED HACE
+Vaya nombrando y señalando cada tarjeta. El efecto acumulativo es el argumento.</a:t>
             </a:r>
             <a:endParaRPr lang="en-US" dirty="0"/>
           </a:p>
@@ -2308,7 +2437,14 @@
           <a:p>
             <a:r>
               <a:rPr lang="en-US" dirty="0"/>
-              <a:t>El texto perfecto para explicar por que una alerta bien emitida sigue costando vidas.</a:t>
+              <a:t>USTED DICE
+«Quiero detenerme en Egipto, porque el texto dice algo notable.
+Dios anuncia el granizo con hora. Y el relato dice: “el que tuvo temor de la palabra de Jehová hizo huir sus criados y su ganado a casa; mas el que no puso en su corazón la palabra de Jehová, dejó sus criados y sus ganados en el campo”.
+Misma alerta. Dos respuestas. Dos resultados.
+Ahí está toda la gestión de riesgo en dos versículos. Y ahí está la respuesta a por qué, con boletines, con radio, con celulares y con alerta roja declarada, seguimos contando muertos.
+El problema no es la alerta. Es la respuesta.»
+USTED HACE
+Señale las dos columnas. Que la gente vea el contraste antes de que usted lo explique.</a:t>
             </a:r>
             <a:endParaRPr lang="en-US" dirty="0"/>
           </a:p>
@@ -2396,7 +2532,15 @@
           <a:p>
             <a:r>
               <a:rPr lang="en-US" dirty="0"/>
-              <a:t>El boletin de meteorologia, la alerta de Defensa Civil y la sirena del bombero cumplen una funcion que la Biblia considera sagrada.</a:t>
+              <a:t>USTED DICE
+«Dios no solo avisa: Dios levanta gente que avisa, y le da a ese oficio una dignidad enorme.
+El atalaya de Ezequiel 33, puesto en la muralla para ver antes que nadie.
+Las trompetas de plata de Números 10: un sistema de señales acordado, con un toque para convocar y otro para dar alarma.
+Nehemías 4:20: “donde oyereis el sonido de la trompeta, reuníos allí con nosotros”. Eso es un punto de encuentro. Nehemías tenía punto de encuentro.
+Y Amós 3:6: “¿se tocará la trompeta en la ciudad, y no se alborotará el pueblo?”. Amós da por sentado que la reacción normal ante una alarma es moverse, no quedarse discutiendo si es real.»
+CIERRE DE LA DIAPOSITIVA
+«Cuando la oficina de meteorología emite un boletín, cuando Defensa Civil declara alerta, cuando el bombero toca la sirena: están cumpliendo una función que la Biblia considera sagrada.
+El atalaya no siempre lleva púlpito. A veces lleva casco.»</a:t>
             </a:r>
             <a:endParaRPr lang="en-US" dirty="0"/>
           </a:p>
@@ -2484,7 +2628,12 @@
           <a:p>
             <a:r>
               <a:rPr lang="en-US" dirty="0"/>
-              <a:t>Hagalo de verdad. Espere. Habra manos apuntando a lugares distintos y manos que no se levantan.</a:t>
+              <a:t>USTED DICE
+«Vamos a ver. Sin moverse de su asiento: señale con la mano la salida más cercana a usted.»
+USTED HACE
+Hágalo de verdad y espere. Va a haber manos apuntando a lugares distintos, y manos que no se levantan. No corrija a nadie: deje que lo vean.
+USTED DICE
+«Miren a su alrededor. No todos apuntamos al mismo lugar. Y algunos no apuntaron. Eso no es un problema de fe. Es un problema de preparación. Y la Biblia tiene mucho, muchísimo que decir sobre eso.»</a:t>
             </a:r>
             <a:endParaRPr lang="en-US" dirty="0"/>
           </a:p>
@@ -2572,7 +2721,16 @@
           <a:p>
             <a:r>
               <a:rPr lang="en-US" dirty="0"/>
-              <a:t>Despues del desastre, que queda en pie en el barrio? El templo. Quien tiene la lista de los ancianos solos? Nosotros.</a:t>
+              <a:t>USTED DICE
+«Y después del desastre, Dios manda a socorrer.
+Miren la palabra que usa Hechos 11: los discípulos, cada uno conforme a lo que tenía, determinaron enviar SOCORRO. Ahí está la palabra.
+Y miren el método: aporte según capacidad, recolección organizada, envío por manos responsables. Es una operación de ayuda humanitaria con rendición de cuentas. En el siglo primero.»
+AHORA DÍGALO CON TODAS SUS LETRAS
+«La iglesia es un organismo de socorro. No metafóricamente.
+Después del desastre, ¿qué queda en pie en el barrio? El templo. ¿Quién tiene la lista de los ancianos que viven solos? Nosotros. ¿Quién puede convocar a cien voluntarios en una hora, sin presupuesto y sin contrato? Nosotros.
+Somos, en muchas comunidades, el primer respondiente después del vecino. La pregunta no es si vamos a responder. La pregunta es si vamos a responder preparados o improvisando.»
+TRANSICIÓN
+«Entonces, si Dios avisa, si Dios manda a avisar y si Dios manda a socorrer, la pregunta se cae de madura: ¿cómo se prepara un cristiano?»</a:t>
             </a:r>
             <a:endParaRPr lang="en-US" dirty="0"/>
           </a:p>
@@ -2660,7 +2818,14 @@
           <a:p>
             <a:r>
               <a:rPr lang="en-US" dirty="0"/>
-              <a:t>Alista el caballo. Confia en Jehova. Las dos cosas, en la misma frase.</a:t>
+              <a:t>USTED DICE
+«Hay dos errores, y los dos son peligrosos.
+El primero: el fatalismo espiritual. “Si Dios me va a guardar, ¿para qué me preparo?”. Suena espiritual. No lo es. Es la misma lógica que usó Satanás en la tentación: tírate del pináculo, que los ángeles te sostendrán. ¿Y qué contestó Jesús? “No tentarás al Señor tu Dios”.
+Exponerse voluntariamente al peligro y llamarlo fe, Jesús lo llamó tentar a Dios.
+El segundo: el pánico acumulador. El que ve noticias todo el día, llena la casa de provisiones y vive con el estómago apretado. Eso tampoco es fe. Eso es miedo con logística.
+Entre esos dos extremos está el camino bíblico: prudencia serena.
+Proverbios 21:31 lo dice perfecto: “el caballo se alista para el día de la batalla; mas Jehová es el que da la victoria”.
+Alista el caballo. Confía en Jehová. Las dos cosas, en la misma frase.»</a:t>
             </a:r>
             <a:endParaRPr lang="en-US" dirty="0"/>
           </a:p>
@@ -2748,7 +2913,16 @@
           <a:p>
             <a:r>
               <a:rPr lang="en-US" dirty="0"/>
-              <a:t>El nivel 7 es el llamado mas concreto: que en cada celula haya al menos una persona certificada.</a:t>
+              <a:t>USTED DICE
+No desarrolle los siete. Nómbrelos y deténgase en dos o tres.
+«Espiritual: ninguna mochila le sirve si su casa no está sobre la roca. Y fíjense que en esa parábola las dos casas reciben la misma tormenta. La diferencia no estuvo en el clima: estuvo en el cimiento.
+Mental: infórmese de fuentes oficiales, no de cadenas de WhatsApp. Compartir un rumor en una emergencia es dar falso testimonio con consecuencias físicas. Y racione la noticia: Dios no nos dio espíritu de cobardía, sino de dominio propio.
+Cuerpo y casa: mochila de setenta y dos horas, botiquín con los medicamentos crónicos de la familia — que es lo que más se olvida y lo que más falta hace.
+Económica: José guardó la quinta parte en los años buenos. Un porcentaje, con disciplina, durante siete años.»
+USTED HACE
+Aquí abra la mochila de emergencia que trajo y saque las cosas una por una. Una mochila real vale más que tres diapositivas.
+EL NIVEL 7 ES EL LLAMADO
+«No basta con estar a salvo: Dios nos llamó a socorrer. Quiero que en cada célula, en cada ministerio, haya por lo menos una persona certificada en primeros auxilios. Porque el día del desastre, el que llega primero no es el experto que viene de lejos. El que llega primero es el que ya estaba ahí. Y ese, muchas veces, somos nosotros.»</a:t>
             </a:r>
             <a:endParaRPr lang="en-US" dirty="0"/>
           </a:p>
@@ -2836,7 +3010,18 @@
           <a:p>
             <a:r>
               <a:rPr lang="en-US" dirty="0"/>
-              <a:t>Hagalo esta semana, en la mesa, con los muchachos. Corto, claro, y que todos lo sepan.</a:t>
+              <a:t>USTED DICE
+«Cinco preguntas que toda familia debe poder responder sin pensar.
+¿Cuál es nuestro punto de encuentro si no podemos volver a la casa?
+¿Cuál es el segundo punto, fuera del barrio, si no se puede entrar a la zona?
+¿Quién es nuestro contacto fuera de la ciudad, al que todos llamamos si no logramos comunicarnos entre nosotros?
+¿Quién recoge a los niños, y la escuela sabe que esa persona está autorizada?
+Y ¿quién responde por el familiar vulnerable: el anciano, el enfermo, la persona con discapacidad, la embarazada?»
+EL REMATE
+«Ese plan hay que escribirlo y practicarlo. Un plan que solo existe en su cabeza no es un plan: es una intención.
+Háganlo esta semana, en la mesa, con los muchachos. Que sea corto. Que sea claro. Que todos lo sepan. Está en la hoja que les entregamos, en el reverso.»
+TRANSICIÓN
+«Ahora bien, hay una pregunta que no podemos esquivar, porque es la que la gente hace de verdad cuando el techo se cae: ¿por qué? ¿Es Dios el que manda el huracán?»</a:t>
             </a:r>
             <a:endParaRPr lang="en-US" dirty="0"/>
           </a:p>
@@ -2924,7 +3109,13 @@
           <a:p>
             <a:r>
               <a:rPr lang="en-US" dirty="0"/>
-              <a:t/>
+              <a:t>BLOQUE 4 · 13 minutos
+ADVERTENCIA PASTORAL
+Aquí hay dolor real en el auditorio. Habrá quien perdió casa, o perdió gente. Hable despacio y no use este bloque para especular sobre profecía. Úselo para dar suelo firme.
+USTED DICE
+«Hay una pregunta que no podemos esquivar, porque es la que la gente hace de verdad cuando el techo se cae: ¿por qué?
+¿Es Dios el que manda el huracán? ¿Es castigo? ¿Qué enseña la Biblia sobre los fenómenos de la naturaleza?»
+Si sabe que hay personas de duelo en la sala, reconózcalo aquí: «sé que aquí hay quien enterró a alguien después de una tormenta; lo que voy a decir lo digo con respeto, no desde la teoría».</a:t>
             </a:r>
             <a:endParaRPr lang="en-US" dirty="0"/>
           </a:p>
@@ -3012,7 +3203,15 @@
           <a:p>
             <a:r>
               <a:rPr lang="en-US" dirty="0"/>
-              <a:t>Aqui hay dolor real en el auditorio. Hable despacio. No especule sobre profecia.</a:t>
+              <a:t>ADVERTENCIA PASTORAL
+Aquí hay dolor real en el auditorio. Habrá quien perdió casa, o perdió gente. Hable despacio. Si lo sabe, dígalo al entrar: «sé que aquí hay quien enterró a alguien después de una tormenta; lo que voy a decir lo digo con respeto, no desde la teoría». No use este bloque para especular sobre profecía.
+USTED DICE — verdad por verdad
+«Uno: la creación es de Dios, y Él le puso límites. Dios le dice al mar: “hasta aquí llegarás”. El mar tiene un límite, y el límite no se lo puso el mar.
+Dos: la creación está herida y gime. Y fíjense en la imagen que escoge Pablo: dolores de parto. No es la agonía de algo que se muere: es el dolor de algo que está por nacer.
+Tres: hay un orden natural que Dios sostiene. Las placas se mueven porque la tierra es un planeta vivo. Los ciclones se forman porque el mar se calienta. Eso no es magia negra ni es demonio: es física — y la física la escribió Dios.
+Cuatro, y es la más importante: la Biblia prohíbe culpar a la víctima. La vemos en la próxima diapositiva.
+Cinco: Dios habla, pero no se reduce al fenómeno. Elías lo esperaba en el viento, en el terremoto y en el fuego, y Dios llegó en un silbo apacible.
+Seis: la historia no termina en catástrofe. Termina con Dios secando lágrimas, una por una, con sus manos.»</a:t>
             </a:r>
             <a:endParaRPr lang="en-US" dirty="0"/>
           </a:p>
@@ -3100,7 +3299,14 @@
           <a:p>
             <a:r>
               <a:rPr lang="en-US" dirty="0"/>
-              <a:t>Jesus rechaza expresamente la ecuacion "les paso porque eran peores". Job 42:7 dice lo mismo de los amigos de Job.</a:t>
+              <a:t>USTED DICE
+«Le cuentan a Jesús de una tragedia, y Él mismo trae otra: la torre de Siloé, que cayó y mató a dieciocho personas.
+Y pregunta: “¿pensáis que eran más culpables que todos los hombres que habitan en Jerusalén?”.
+Y contesta Él mismo: “Os digo: No”.
+Jesús, con una tragedia sobre la mesa, rechaza expresamente la ecuación “les pasó porque eran peores”. La rechaza. Y en vez de darles un culpable les da un espejo: “si no os arrepentís, todos pereceréis igualmente”.
+La tragedia ajena no es material de diagnóstico. Es llamado propio.»
+SI QUIERE REFORZAR
+Los amigos de Job hicieron exactamente lo que Jesús prohíbe, y al final Dios les dijo que no habían hablado de Él lo recto (Job 42:7). Y en Juan 9, ante la pregunta “¿quién pecó, éste o sus padres?”, Jesús responde que ni uno ni otro: la pregunta estaba mal formulada.</a:t>
             </a:r>
             <a:endParaRPr lang="en-US" dirty="0"/>
           </a:p>
@@ -3188,7 +3394,14 @@
           <a:p>
             <a:r>
               <a:rPr lang="en-US" dirty="0"/>
-              <a:t>Este es el punto pastoral del bloque. Digalo despacio.</a:t>
+              <a:t>USTED DICE
+Este es el punto pastoral del bloque. Dígalo despacio, sin levantar la voz.
+«Entonces, cuando pase un desastre, no salga a decir por qué Dios lo mandó.
+Salga con agua, con comida y con brazos.
+La teología del que sufre se hace cargando colchones, no dando explicaciones.»
+USTED HACE
+Deje un silencio después de la última frase. Luego pase a los ejemplos bíblicos con la transición:
+«Déjenme cerrar mostrándoles gente. Porque la Biblia no nos dio una teoría del desastre: nos dio rostros.»</a:t>
             </a:r>
             <a:endParaRPr lang="en-US" dirty="0"/>
           </a:p>
@@ -3276,7 +3489,13 @@
           <a:p>
             <a:r>
               <a:rPr lang="en-US" dirty="0"/>
-              <a:t/>
+              <a:t>BLOQUE 5 · 10 minutos
+USTED DICE
+«Déjenme cerrar mostrándoles gente. Porque la Biblia no nos dio una teoría del desastre: nos dio rostros.»
+RITMO
+Son cinco ejemplos en diez minutos. Minuto y medio cada uno. No los desarrolle todos ni se enamore de uno: el peso acumulado es el argumento.
+SI LE FALTA TIEMPO
+Quédese con tres: Noé (prevención), José (planificación) y Hechos 27 (la promesa no sustituye a la tripulación).</a:t>
             </a:r>
             <a:endParaRPr lang="en-US" dirty="0"/>
           </a:p>
@@ -3364,7 +3583,14 @@
           <a:p>
             <a:r>
               <a:rPr lang="en-US" dirty="0"/>
-              <a:t>El arca fue "en que su casa se salvase": la preparacion del creyente cubre a los suyos.</a:t>
+              <a:t>USTED DICE
+«“Por la fe Noé, cuando fue advertido por Dios acerca de cosas que aún no se veían, con temor preparó el arca en que su casa se salvase”.
+Subrayen tres cosas de ese versículo: fue ADVERTIDO; las cosas AÚN NO SE VEÍAN; y él PREPARÓ.
+La construcción del arca fue un acto de fe con planos, con medidas y con materiales. Dios le dio dimensiones exactas y un tipo de madera. La fe de Noé se midió en codos.
+Y aquí está lo que más me impresiona: Noé se preparó años antes, mientras el cielo seguía azul y los vecinos se reían.
+Eso es prevención: trabajar hoy por un riesgo que hoy no se ve.»
+AGREGUE
+El arca fue “en que su casa se salvase”: la preparación del creyente cubre a los suyos, no solo a él.</a:t>
             </a:r>
             <a:endParaRPr lang="en-US" dirty="0"/>
           </a:p>
@@ -3452,7 +3678,12 @@
           <a:p>
             <a:r>
               <a:rPr lang="en-US" dirty="0"/>
-              <a:t>Dios invento el sistema de alerta temprana y lo puso en manos de su pueblo.</a:t>
+              <a:t>USTED DICE
+«El tema de hoy es Organismos de Socorro y la Biblia. Y quiero desarmar, desde el primer minuto, la idea de que estos son dos mundos separados: que la Defensa Civil, la Cruz Roja y los bomberos van por un lado, y la Biblia va por otro. No es así.»
+Lea el versículo completo, despacio. Luego:
+«El atalaya no detiene la espada. No controla al enemigo. El atalaya tiene una sola responsabilidad: ver a tiempo y avisar a tiempo.
+Eso es exactamente lo que hace un sistema de alerta temprana. Eso es lo que hace un boletín de meteorología. Eso es lo que hace un detector de humo a las tres de la mañana.
+Dios inventó el sistema de alerta temprana. Y lo puso en manos de su pueblo.»</a:t>
             </a:r>
             <a:endParaRPr lang="en-US" dirty="0"/>
           </a:p>
@@ -3540,7 +3771,15 @@
           <a:p>
             <a:r>
               <a:rPr lang="en-US" dirty="0"/>
-              <a:t>Es el modelo biblico del plan nacional de gestion de riesgo y del fondo de contingencia.</a:t>
+              <a:t>USTED DICE
+«José recibe el aviso de siete años de hambre, y no monta una campaña de oración solamente: diseña un plan de veinte años.
+Nombra un responsable. Establece una reserva del veinte por ciento. Construye almacenes. Administra el inventario. Y en la crisis distribuye ordenadamente.
+El texto dice que guardaron “como la arena del mar, mucho en extremo, hasta no poderse contar”.
+Resultado: Egipto no pereció de hambre, y las naciones de alrededor tampoco, porque venían a comprar.
+La previsión de un hombre justo alimentó a un continente.»
+EL PUENTE A HOY
+«Eso es lo que hace hoy un plan nacional de gestión de riesgo, una reserva estratégica, un fondo de contingencia. Y su modelo es José.
+Y fíjense que José no lo guardó todo ni lo consumió todo: guardó un porcentaje, con disciplina, durante siete años seguidos. Eso es lo que hace falta en una casa y en una iglesia.»</a:t>
             </a:r>
             <a:endParaRPr lang="en-US" dirty="0"/>
           </a:p>
@@ -3628,7 +3867,15 @@
           <a:p>
             <a:r>
               <a:rPr lang="en-US" dirty="0"/>
-              <a:t>Nehemias 4:20 es el punto de encuentro: "donde oyereis el sonido de la trompeta, reunios alli".</a:t>
+              <a:t>USTED DICE
+«Amenaza real, enemigos reales. ¿Qué hizo Nehemías? “Oramos a nuestro Dios, y por causa de ellos pusimos guarda contra ellos de día y de noche”.
+Y montó un sistema completo. Miren:
+Vigilancia: turnos de día y de noche, con relevo.
+Alerta: un trompetista al lado del líder, para que la señal saliera de un solo punto.
+Concentración: un punto de reunión acordado de antemano — “en el lugar donde oyereis el sonido de la trompeta, reuníos allí con nosotros”.
+Respuesta: una mano en la obra, la otra en el arma.
+Alerta, evacuación, concentración, respuesta. Nehemías tenía un protocolo de emergencia. En el siglo quinto antes de Cristo.
+Y no dejó de construir el muro por eso.»</a:t>
             </a:r>
             <a:endParaRPr lang="en-US" dirty="0"/>
           </a:p>
@@ -3716,7 +3963,16 @@
           <a:p>
             <a:r>
               <a:rPr lang="en-US" dirty="0"/>
-              <a:t>Tenia a la vez palabra de Dios y cabeza fria. Esa combinacion es la que hace falta en la cubierta.</a:t>
+              <a:t>USTED DICE
+Cuente la historia, no la lea. Vaya señalando cada línea.
+«Uno: Pablo advierte el riesgo antes de zarpar. Y le ignoran. Al experto lo ignoran, porque el piloto y el dueño del barco tenían prisa. Eso pasa todos los días.
+Dos: cuando revienta la tormenta, Pablo no dice “se lo dije”. Se pone de pie y dice: “tened buen ánimo”.
+Tres: y da la razón de su calma. “Creo a Dios que será así como se me ha dicho”. Su serenidad tenía fundamento: no era negación.
+Cuatro: detecta a los marineros que intentaban escapar en la lancha y avisa: “si éstos no permanecen en la nave, vosotros no podéis salvaros”.
+Cinco: los hace comer para que tengan fuerzas. Cuida lo físico, no solo lo espiritual.
+Seis: da gracias a Dios delante de todos, en medio del temporal.
+Y el versículo 44: “y así aconteció que todos se salvaron saliendo a tierra”. Doscientas setenta y seis personas. Ni una perdida.
+Un preso a bordo terminó dirigiendo el rescate, porque era el único que tenía a la vez palabra de Dios y cabeza fría.»</a:t>
             </a:r>
             <a:endParaRPr lang="en-US" dirty="0"/>
           </a:p>
@@ -3804,7 +4060,15 @@
           <a:p>
             <a:r>
               <a:rPr lang="en-US" dirty="0"/>
-              <a:t>Dios habia prometido que todos se salvarian, y aun asi hacia falta que los hombres capacitados se quedaran en su puesto.</a:t>
+              <a:t>USTED DICE
+«Quiero que se lleven este versículo por encima de todos los demás de la noche.
+Dios ya había prometido, por boca de un ángel, que no se perdería ni una sola vida. Ya estaba prometido.
+Y aun así, cuando los marineros intentan huir en la lancha, Pablo dice: “si éstos no permanecen en la nave, vosotros no podéis salvaros”.
+Escuchen bien: la promesa de Dios no anulaba la necesidad de la tripulación. Hacía falta que los hombres capacitados se quedaran en su puesto.
+La promesa de Dios no sustituye a la tripulación.
+Escriban eso. Porque cada vez que alguien diga que prepararse es falta de fe, la respuesta está en Hechos 27:31.»
+USTED HACE
+Deje silencio después de la frase final. Es el cierre argumental de toda la conferencia.</a:t>
             </a:r>
             <a:endParaRPr lang="en-US" dirty="0"/>
           </a:p>
@@ -3892,7 +4156,16 @@
           <a:p>
             <a:r>
               <a:rPr lang="en-US" dirty="0"/>
-              <a:t>Es una operacion de ayuda humanitaria con destino verificado y rendicion de cuentas. 2 Corintios 8:20-21.</a:t>
+              <a:t>USTED DICE
+«Llega Agabo a Antioquía y anuncia una gran hambre. ¿Qué hace la iglesia?
+“Entonces los discípulos, cada uno conforme a lo que tenía, determinaron enviar socorro a los hermanos”.
+Miren la cadena: aviso, decisión, aporte según capacidad, recolección, y envío por manos responsables — Bernabé y Saulo.
+Eso, hermanos, es un operativo de ayuda humanitaria, con transparencia y con destino verificado. Y nació de una iglesia local.
+Cuando esta iglesia organiza un centro de acopio, no está copiando a las ONG. Está copiando a Antioquía.»
+SI QUIERE AGREGAR
+Pablo organiza otra colecta en 2 Corintios 8 y 9, y ahí dice algo que toda iglesia debería tener enmarcado: “evitando que nadie nos censure en cuanto a esta ofrenda abundante”. Transparencia total en el manejo de la ayuda.
+MENCIÓN RÁPIDA (30 segundos, si hay tiempo)
+Las ciudades de refugio de Números 35 y Josué 20: refugios designados de antemano, distribuidos geográficamente, con los caminos arreglados para que el que huye llegue a tiempo. Y Rahab en Josué 2: la señal en la ventana, la familia reunida adentro, y la instrucción de no salir de la casa.</a:t>
             </a:r>
             <a:endParaRPr lang="en-US" dirty="0"/>
           </a:p>
@@ -3980,7 +4253,13 @@
           <a:p>
             <a:r>
               <a:rPr lang="en-US" dirty="0"/>
-              <a:t>Cuatro frases, no mas. Despues pase directo al llamado.</a:t>
+              <a:t>USTED DICE
+Cuatro frases, no más. No las desarrolle: ya las desarrolló toda la noche. Después pase directo al llamado.
+«Cuatro cosas para llevarse:
+Uno: Dios avisa. Siempre avisó. Antes de Noé, antes de José, antes del naufragio. El sistema de alerta temprana es idea suya.
+Dos: prepararse es obediencia, no incredulidad. Oramos Y ponemos guarda.
+Tres: la tragedia no es sentencia. Jesús mismo prohibió esa lectura en Lucas 13. Frente al que sufre no vamos con explicaciones: vamos con las manos.
+Cuatro: la iglesia es un organismo de socorro. Y el que llega primero es el que ya estaba ahí.»</a:t>
             </a:r>
             <a:endParaRPr lang="en-US" dirty="0"/>
           </a:p>
@@ -4068,7 +4347,17 @@
           <a:p>
             <a:r>
               <a:rPr lang="en-US" dirty="0"/>
-              <a:t>Pida que levanten la mano para la lista de la brigada. Que salgan nombres anotados de verdad.</a:t>
+              <a:t>USTED DICE
+«No quiero aplausos. Quiero decisiones. Tres, y son de esta semana.
+Primero, el plan de mi casa. Esta semana, en la mesa, con la familia: punto de encuentro, contacto, mochila. Está en la hoja que les entregamos, en el reverso. Escríbanlo. No lo piensen: escríbanlo.
+Segundo, capacitarme. Quiero que salgan de aquí nombres anotados para el curso de primeros auxilios y para la brigada de esta iglesia.»
+USTED HACE
+Pida que levanten la mano ahora mismo. Tenga a alguien anotando nombres de verdad, con papel, en la puerta. Si no sale una lista esta noche, no sale nunca.
+USTED DICE
+«Y tercero, mi vecino. Piense en una persona de su cuadra que no podría salir sola: el anciano, el enfermo, la señora con el niño pequeño, la persona con discapacidad.
+Póngale nombre. Ahora mismo, en su mente, póngale nombre.
+Y comprométase delante de Dios a que, si pasa algo, usted toca esa puerta antes de irse.
+Eso es amar al prójimo con un plan.»</a:t>
             </a:r>
             <a:endParaRPr lang="en-US" dirty="0"/>
           </a:p>
@@ -4156,7 +4445,16 @@
           <a:p>
             <a:r>
               <a:rPr lang="en-US" dirty="0"/>
-              <a:t>Cierre con la oracion sugerida en el guion.</a:t>
+              <a:t>USTED DICE
+«Termino donde empecé, con el atalaya de Ezequiel.
+El atalaya no podía detener la espada. Usted no puede detener el huracán, ni el temblor, ni el fuego. Nadie se lo está pidiendo.
+Pero el atalaya sí podía ver a tiempo y avisar a tiempo. Y de eso, dice Dios, sí somos responsables.
+Hoy usted vio. Ya no puede decir que no sabía.
+Ahora toque la trompeta en su casa.»
+ORACIÓN DE CIERRE
+«Señor, tú eres nuestro amparo y fortaleza, nuestro pronto auxilio en las tribulaciones. Gracias porque nunca nos has dejado sin aviso. Perdónanos por las veces que llamamos fe a lo que era descuido, y por las veces que llamamos prudencia a lo que era miedo. Danos manos preparadas y corazón sereno. Que cuando la tierra se mueva, tu pueblo no corra: sirva. Y haznos, en el barrio donde nos pusiste, la casa a la que la gente sabe que puede tocar. En el nombre de Jesús, amén.»
+DESPUÉS
+Quédese disponible. Alguien va a querer hablar.</a:t>
             </a:r>
             <a:endParaRPr lang="en-US" dirty="0"/>
           </a:p>
@@ -4244,7 +4542,11 @@
           <a:p>
             <a:r>
               <a:rPr lang="en-US" dirty="0"/>
-              <a:t>De esta frase no se mueva en 90 minutos.</a:t>
+              <a:t>USTED DICE
+«Escuchen bien esta frase, porque de aquí no me voy a mover en noventa minutos:
+Prepararse no es desconfiar de Dios. Prepararse es obedecer a Dios.»
+USTED HACE
+Dígala dos veces. La segunda, más lento. Es la tesis de toda la conferencia y todo lo demás cuelga de ella. No la explique todavía: la próxima diapositiva la sustenta.</a:t>
             </a:r>
             <a:endParaRPr lang="en-US" dirty="0"/>
           </a:p>
@@ -4332,7 +4634,11 @@
           <a:p>
             <a:r>
               <a:rPr lang="en-US" dirty="0"/>
-              <a:t>Este versiculo resuelve el falso dilema entre orar y prepararse.</a:t>
+              <a:t>USTED DICE
+«Nehemías lo dijo en seis palabras: “Oramos a nuestro Dios, y… pusimos guarda”.
+La conjunción es Y. No es O. Nehemías no escogió entre orar y montar guardia: hizo las dos cosas la misma noche.»
+USTED HACE
+Señale la Y grande de la pantalla. Este versículo resuelve el falso dilema que trae en la cabeza la mitad del auditorio, y al que van a volver cuando usted hable de mochilas y extintores. Déjelo bien clavado aquí.</a:t>
             </a:r>
             <a:endParaRPr lang="en-US" dirty="0"/>
           </a:p>
@@ -4420,7 +4726,11 @@
           <a:p>
             <a:r>
               <a:rPr lang="en-US" dirty="0"/>
-              <a:t>Prometa que nadie sale igual: todos salen con un plan escrito.</a:t>
+              <a:t>USTED DICE
+«Vamos a hacer cuatro cosas. Primero, lo práctico: qué hacer ante un terremoto, un ciclón, un maremoto, un incendio y un accidente. Segundo, qué habla Dios ante las emergencias. Tercero, cómo se prepara un cristiano en un mundo lleno de amenazas. Y cuarto, qué nos enseña la Escritura sobre los fenómenos de la naturaleza, con ejemplos bíblicos que van a cambiar la forma en que usted lee esas historias.
+Y les hago una promesa: nadie sale de aquí igual que como entró. Van a salir con un plan escrito. Uno de verdad.»
+TRANSICIÓN
+«Empecemos por lo más urgente. Porque si la tierra tiembla mientras hablamos de teología, la teología no le va a servir de nada si no sabe qué hacer con su cuerpo en los próximos diez segundos.»</a:t>
             </a:r>
             <a:endParaRPr lang="en-US" dirty="0"/>
           </a:p>
@@ -4508,7 +4818,13 @@
           <a:p>
             <a:r>
               <a:rPr lang="en-US" dirty="0"/>
-              <a:t/>
+              <a:t>BLOQUE 1 · 25 minutos
+USTED DICE
+«Empecemos por lo más urgente, y después vamos a la Biblia. Porque si la tierra tiembla mientras estamos hablando de teología, la teología no le va a servir de nada si usted no sabe qué hacer con su cuerpo en los próximos diez segundos.»
+REGLA DEL BLOQUE
+No intente cubrirlo todo. Enseñe pocas acciones, bien memorizadas. Una acción que la gente recuerda vale más que veinte que olvida.
+CONTROLE EL RELOJ
+Este es el bloque más fácil de dictar y el que más tienta a extenderse. Si se pasa, le va a quitar minutos al Bloque 2 — que es el corazón de la conferencia.</a:t>
             </a:r>
             <a:endParaRPr lang="en-US" dirty="0"/>
           </a:p>
@@ -4596,7 +4912,13 @@
           <a:p>
             <a:r>
               <a:rPr lang="en-US" dirty="0"/>
-              <a:t>Dinamica de 60 segundos: todos de pie, a la cuenta de tres. Cuente diez segundos en voz alta.</a:t>
+              <a:t>USTED DICE
+«El salmista nombra el terremoto. No lo niega, no pretende que no existe. Dice: aunque la tierra sea removida, no temeremos. La fe bíblica no cierra los ojos ante el peligro: los abre y no se paraliza.
+Y en una emergencia usted no se va a elevar a la altura de sus intenciones. Usted va a caer a la altura de su entrenamiento. Por eso vamos a practicar, no solo a escuchar.»
+DINÁMICA (60 segundos — hágala)
+«De pie. Todos. A la cuenta de tres: agáchese, cúbrase la cabeza con los brazos, y agárrese de la silla. Uno… dos… tres.»
+Cuente diez segundos en voz alta. Que sientan lo largos que son.
+«Eso fue lo que duró el terremoto que destruyó buena parte de Puerto Príncipe. Diez segundos. Siéntense.»</a:t>
             </a:r>
             <a:endParaRPr lang="en-US" dirty="0"/>
           </a:p>

</xml_diff>